<commit_message>
update presentation from Viktor
</commit_message>
<xml_diff>
--- a/DPO Group 1 Presentation.pptx
+++ b/DPO Group 1 Presentation.pptx
@@ -5,10 +5,10 @@
     <p:sldMasterId id="2147483684" r:id="rId4"/>
   </p:sldMasterIdLst>
   <p:notesMasterIdLst>
-    <p:notesMasterId r:id="rId16"/>
+    <p:notesMasterId r:id="rId15"/>
   </p:notesMasterIdLst>
   <p:handoutMasterIdLst>
-    <p:handoutMasterId r:id="rId17"/>
+    <p:handoutMasterId r:id="rId16"/>
   </p:handoutMasterIdLst>
   <p:sldIdLst>
     <p:sldId id="278" r:id="rId5"/>
@@ -18,10 +18,9 @@
     <p:sldId id="284" r:id="rId9"/>
     <p:sldId id="285" r:id="rId10"/>
     <p:sldId id="286" r:id="rId11"/>
-    <p:sldId id="287" r:id="rId12"/>
-    <p:sldId id="289" r:id="rId13"/>
-    <p:sldId id="288" r:id="rId14"/>
-    <p:sldId id="292" r:id="rId15"/>
+    <p:sldId id="289" r:id="rId12"/>
+    <p:sldId id="288" r:id="rId13"/>
+    <p:sldId id="292" r:id="rId14"/>
   </p:sldIdLst>
   <p:sldSz cx="12192000" cy="6858000"/>
   <p:notesSz cx="6858000" cy="9144000"/>
@@ -238,7 +237,7 @@
             <a:pPr rtl="0"/>
             <a:fld id="{BC1A1616-714D-4ADA-BBBA-B34ABEEC5283}" type="datetime1">
               <a:rPr lang="ru-RU" smtClean="0"/>
-              <a:t>24.05.2026</a:t>
+              <a:t>26.05.2026</a:t>
             </a:fld>
             <a:endParaRPr lang="ru-RU" dirty="0"/>
           </a:p>
@@ -419,7 +418,7 @@
             <a:fld id="{A8D124BC-5E8F-4686-A3D0-46BF78A79F81}" type="datetime1">
               <a:rPr lang="ru-RU" smtClean="0"/>
               <a:pPr/>
-              <a:t>24.05.2026</a:t>
+              <a:t>26.05.2026</a:t>
             </a:fld>
             <a:endParaRPr lang="ru-RU" dirty="0"/>
           </a:p>
@@ -875,100 +874,6 @@
     </p:spTree>
     <p:extLst>
       <p:ext uri="{BB962C8B-B14F-4D97-AF65-F5344CB8AC3E}">
-        <p14:creationId xmlns:p14="http://schemas.microsoft.com/office/powerpoint/2010/main" val="382281238"/>
-      </p:ext>
-    </p:extLst>
-  </p:cSld>
-  <p:clrMapOvr>
-    <a:masterClrMapping/>
-  </p:clrMapOvr>
-</p:notes>
-</file>
-
-<file path=ppt/notesSlides/notesSlide11.xml><?xml version="1.0" encoding="utf-8"?>
-<p:notes xmlns:a="http://schemas.openxmlformats.org/drawingml/2006/main" xmlns:r="http://schemas.openxmlformats.org/officeDocument/2006/relationships" xmlns:p="http://schemas.openxmlformats.org/presentationml/2006/main">
-  <p:cSld>
-    <p:spTree>
-      <p:nvGrpSpPr>
-        <p:cNvPr id="1" name=""/>
-        <p:cNvGrpSpPr/>
-        <p:nvPr/>
-      </p:nvGrpSpPr>
-      <p:grpSpPr>
-        <a:xfrm>
-          <a:off x="0" y="0"/>
-          <a:ext cx="0" cy="0"/>
-          <a:chOff x="0" y="0"/>
-          <a:chExt cx="0" cy="0"/>
-        </a:xfrm>
-      </p:grpSpPr>
-      <p:sp>
-        <p:nvSpPr>
-          <p:cNvPr id="2" name="Образ слайда 1"/>
-          <p:cNvSpPr>
-            <a:spLocks noGrp="1" noRot="1" noChangeAspect="1"/>
-          </p:cNvSpPr>
-          <p:nvPr>
-            <p:ph type="sldImg"/>
-          </p:nvPr>
-        </p:nvSpPr>
-        <p:spPr/>
-      </p:sp>
-      <p:sp>
-        <p:nvSpPr>
-          <p:cNvPr id="3" name="Заметки 2"/>
-          <p:cNvSpPr>
-            <a:spLocks noGrp="1"/>
-          </p:cNvSpPr>
-          <p:nvPr>
-            <p:ph type="body" idx="1"/>
-          </p:nvPr>
-        </p:nvSpPr>
-        <p:spPr/>
-        <p:txBody>
-          <a:bodyPr rtlCol="0"/>
-          <a:lstStyle>
-            <a:defPPr>
-              <a:defRPr lang="ru-RU"/>
-            </a:defPPr>
-          </a:lstStyle>
-          <a:p>
-            <a:pPr rtl="0"/>
-            <a:endParaRPr lang="ru-RU" dirty="0"/>
-          </a:p>
-        </p:txBody>
-      </p:sp>
-      <p:sp>
-        <p:nvSpPr>
-          <p:cNvPr id="4" name="Номер слайда 3"/>
-          <p:cNvSpPr>
-            <a:spLocks noGrp="1"/>
-          </p:cNvSpPr>
-          <p:nvPr>
-            <p:ph type="sldNum" sz="quarter" idx="5"/>
-          </p:nvPr>
-        </p:nvSpPr>
-        <p:spPr/>
-        <p:txBody>
-          <a:bodyPr rtlCol="0"/>
-          <a:lstStyle>
-            <a:defPPr>
-              <a:defRPr lang="ru-RU"/>
-            </a:defPPr>
-          </a:lstStyle>
-          <a:p>
-            <a:pPr rtl="0"/>
-            <a:fld id="{E7AF00E9-A49D-4007-B3B9-A3783809E505}" type="slidenum">
-              <a:rPr lang="ru-RU" smtClean="0"/>
-              <a:t>11</a:t>
-            </a:fld>
-            <a:endParaRPr lang="ru-RU" dirty="0"/>
-          </a:p>
-        </p:txBody>
-      </p:sp>
-    </p:spTree>
-    <p:extLst>
-      <p:ext uri="{BB962C8B-B14F-4D97-AF65-F5344CB8AC3E}">
         <p14:creationId xmlns:p14="http://schemas.microsoft.com/office/powerpoint/2010/main" val="1049693401"/>
       </p:ext>
     </p:extLst>
@@ -1627,7 +1532,7 @@
     </p:spTree>
     <p:extLst>
       <p:ext uri="{BB962C8B-B14F-4D97-AF65-F5344CB8AC3E}">
-        <p14:creationId xmlns:p14="http://schemas.microsoft.com/office/powerpoint/2010/main" val="2661674522"/>
+        <p14:creationId xmlns:p14="http://schemas.microsoft.com/office/powerpoint/2010/main" val="1776108762"/>
       </p:ext>
     </p:extLst>
   </p:cSld>
@@ -1721,7 +1626,7 @@
     </p:spTree>
     <p:extLst>
       <p:ext uri="{BB962C8B-B14F-4D97-AF65-F5344CB8AC3E}">
-        <p14:creationId xmlns:p14="http://schemas.microsoft.com/office/powerpoint/2010/main" val="1776108762"/>
+        <p14:creationId xmlns:p14="http://schemas.microsoft.com/office/powerpoint/2010/main" val="382281238"/>
       </p:ext>
     </p:extLst>
   </p:cSld>
@@ -12648,752 +12553,6 @@
       </p:grpSpPr>
       <p:sp>
         <p:nvSpPr>
-          <p:cNvPr id="9" name="Овал 8">
-            <a:extLst>
-              <a:ext uri="{FF2B5EF4-FFF2-40B4-BE49-F238E27FC236}">
-                <a16:creationId xmlns:a16="http://schemas.microsoft.com/office/drawing/2014/main" id="{5C4A7DC2-42C3-FDDF-02BF-9598D75A6A83}"/>
-              </a:ext>
-              <a:ext uri="{C183D7F6-B498-43B3-948B-1728B52AA6E4}">
-                <adec:decorative xmlns:adec="http://schemas.microsoft.com/office/drawing/2017/decorative" val="1"/>
-              </a:ext>
-            </a:extLst>
-          </p:cNvPr>
-          <p:cNvSpPr>
-            <a:spLocks noChangeAspect="1"/>
-          </p:cNvSpPr>
-          <p:nvPr/>
-        </p:nvSpPr>
-        <p:spPr>
-          <a:xfrm>
-            <a:off x="1189378" y="5232629"/>
-            <a:ext cx="1080000" cy="1080000"/>
-          </a:xfrm>
-          <a:prstGeom prst="ellipse">
-            <a:avLst/>
-          </a:prstGeom>
-          <a:gradFill flip="none" rotWithShape="1">
-            <a:gsLst>
-              <a:gs pos="100000">
-                <a:schemeClr val="bg2">
-                  <a:lumMod val="50000"/>
-                  <a:lumOff val="50000"/>
-                </a:schemeClr>
-              </a:gs>
-              <a:gs pos="60000">
-                <a:schemeClr val="bg2">
-                  <a:lumMod val="100000"/>
-                </a:schemeClr>
-              </a:gs>
-            </a:gsLst>
-            <a:path path="circle">
-              <a:fillToRect l="100000" b="100000"/>
-            </a:path>
-            <a:tileRect t="-100000" r="-100000"/>
-          </a:gradFill>
-          <a:ln>
-            <a:noFill/>
-          </a:ln>
-          <a:effectLst>
-            <a:innerShdw blurRad="254000" dist="127000" dir="2700000">
-              <a:schemeClr val="accent1">
-                <a:lumMod val="60000"/>
-                <a:lumOff val="40000"/>
-                <a:alpha val="40000"/>
-              </a:schemeClr>
-            </a:innerShdw>
-            <a:softEdge rad="0"/>
-          </a:effectLst>
-        </p:spPr>
-        <p:style>
-          <a:lnRef idx="2">
-            <a:schemeClr val="accent1">
-              <a:shade val="50000"/>
-            </a:schemeClr>
-          </a:lnRef>
-          <a:fillRef idx="1">
-            <a:schemeClr val="accent1"/>
-          </a:fillRef>
-          <a:effectRef idx="0">
-            <a:schemeClr val="accent1"/>
-          </a:effectRef>
-          <a:fontRef idx="minor">
-            <a:schemeClr val="lt1"/>
-          </a:fontRef>
-        </p:style>
-        <p:txBody>
-          <a:bodyPr rot="0" spcFirstLastPara="0" vertOverflow="overflow" horzOverflow="overflow" vert="horz" wrap="square" lIns="91440" tIns="45720" rIns="91440" bIns="45720" numCol="1" spcCol="0" rtlCol="0" fromWordArt="0" anchor="ctr" anchorCtr="0" forceAA="0" compatLnSpc="1">
-            <a:prstTxWarp prst="textNoShape">
-              <a:avLst/>
-            </a:prstTxWarp>
-            <a:noAutofit/>
-          </a:bodyPr>
-          <a:lstStyle>
-            <a:defPPr>
-              <a:defRPr lang="ru-RU"/>
-            </a:defPPr>
-          </a:lstStyle>
-          <a:p>
-            <a:pPr algn="ctr" rtl="0"/>
-            <a:endParaRPr lang="ru-RU" dirty="0">
-              <a:latin typeface="Calibri" panose="020F0502020204030204" pitchFamily="34" charset="0"/>
-            </a:endParaRPr>
-          </a:p>
-        </p:txBody>
-      </p:sp>
-      <p:grpSp>
-        <p:nvGrpSpPr>
-          <p:cNvPr id="4" name="Группа 3">
-            <a:extLst>
-              <a:ext uri="{FF2B5EF4-FFF2-40B4-BE49-F238E27FC236}">
-                <a16:creationId xmlns:a16="http://schemas.microsoft.com/office/drawing/2014/main" id="{21106B59-80B8-CEED-0BCA-BC3F80A85FEA}"/>
-              </a:ext>
-              <a:ext uri="{C183D7F6-B498-43B3-948B-1728B52AA6E4}">
-                <adec:decorative xmlns:adec="http://schemas.microsoft.com/office/drawing/2017/decorative" val="1"/>
-              </a:ext>
-            </a:extLst>
-          </p:cNvPr>
-          <p:cNvGrpSpPr/>
-          <p:nvPr/>
-        </p:nvGrpSpPr>
-        <p:grpSpPr>
-          <a:xfrm>
-            <a:off x="4803321" y="682622"/>
-            <a:ext cx="734257" cy="760506"/>
-            <a:chOff x="5243759" y="1363788"/>
-            <a:chExt cx="734257" cy="760506"/>
-          </a:xfrm>
-        </p:grpSpPr>
-        <p:sp>
-          <p:nvSpPr>
-            <p:cNvPr id="6" name="Полилиния 5">
-              <a:extLst>
-                <a:ext uri="{FF2B5EF4-FFF2-40B4-BE49-F238E27FC236}">
-                  <a16:creationId xmlns:a16="http://schemas.microsoft.com/office/drawing/2014/main" id="{73C2F317-81E4-3678-2FF2-495B3A95470A}"/>
-                </a:ext>
-              </a:extLst>
-            </p:cNvPr>
-            <p:cNvSpPr>
-              <a:spLocks/>
-            </p:cNvSpPr>
-            <p:nvPr/>
-          </p:nvSpPr>
-          <p:spPr bwMode="auto">
-            <a:xfrm rot="1800000">
-              <a:off x="5356930" y="1363788"/>
-              <a:ext cx="621086" cy="364601"/>
-            </a:xfrm>
-            <a:custGeom>
-              <a:avLst/>
-              <a:gdLst>
-                <a:gd name="T0" fmla="*/ 266 w 540"/>
-                <a:gd name="T1" fmla="*/ 0 h 317"/>
-                <a:gd name="T2" fmla="*/ 0 w 540"/>
-                <a:gd name="T3" fmla="*/ 158 h 317"/>
-                <a:gd name="T4" fmla="*/ 266 w 540"/>
-                <a:gd name="T5" fmla="*/ 317 h 317"/>
-                <a:gd name="T6" fmla="*/ 540 w 540"/>
-                <a:gd name="T7" fmla="*/ 158 h 317"/>
-                <a:gd name="T8" fmla="*/ 266 w 540"/>
-                <a:gd name="T9" fmla="*/ 0 h 317"/>
-              </a:gdLst>
-              <a:ahLst/>
-              <a:cxnLst>
-                <a:cxn ang="0">
-                  <a:pos x="T0" y="T1"/>
-                </a:cxn>
-                <a:cxn ang="0">
-                  <a:pos x="T2" y="T3"/>
-                </a:cxn>
-                <a:cxn ang="0">
-                  <a:pos x="T4" y="T5"/>
-                </a:cxn>
-                <a:cxn ang="0">
-                  <a:pos x="T6" y="T7"/>
-                </a:cxn>
-                <a:cxn ang="0">
-                  <a:pos x="T8" y="T9"/>
-                </a:cxn>
-              </a:cxnLst>
-              <a:rect l="0" t="0" r="r" b="b"/>
-              <a:pathLst>
-                <a:path w="540" h="317">
-                  <a:moveTo>
-                    <a:pt x="266" y="0"/>
-                  </a:moveTo>
-                  <a:lnTo>
-                    <a:pt x="0" y="158"/>
-                  </a:lnTo>
-                  <a:lnTo>
-                    <a:pt x="266" y="317"/>
-                  </a:lnTo>
-                  <a:lnTo>
-                    <a:pt x="540" y="158"/>
-                  </a:lnTo>
-                  <a:lnTo>
-                    <a:pt x="266" y="0"/>
-                  </a:lnTo>
-                  <a:close/>
-                </a:path>
-              </a:pathLst>
-            </a:custGeom>
-            <a:gradFill flip="none" rotWithShape="1">
-              <a:gsLst>
-                <a:gs pos="20000">
-                  <a:schemeClr val="bg2">
-                    <a:lumMod val="90000"/>
-                    <a:lumOff val="10000"/>
-                    <a:alpha val="20000"/>
-                  </a:schemeClr>
-                </a:gs>
-                <a:gs pos="100000">
-                  <a:schemeClr val="accent1">
-                    <a:lumMod val="60000"/>
-                    <a:lumOff val="40000"/>
-                    <a:alpha val="20000"/>
-                  </a:schemeClr>
-                </a:gs>
-              </a:gsLst>
-              <a:lin ang="0" scaled="0"/>
-              <a:tileRect/>
-            </a:gradFill>
-            <a:ln>
-              <a:noFill/>
-            </a:ln>
-            <a:effectLst>
-              <a:innerShdw blurRad="254000">
-                <a:schemeClr val="bg2">
-                  <a:lumMod val="90000"/>
-                  <a:lumOff val="10000"/>
-                </a:schemeClr>
-              </a:innerShdw>
-            </a:effectLst>
-          </p:spPr>
-          <p:style>
-            <a:lnRef idx="2">
-              <a:schemeClr val="accent1">
-                <a:shade val="50000"/>
-              </a:schemeClr>
-            </a:lnRef>
-            <a:fillRef idx="1">
-              <a:schemeClr val="accent1"/>
-            </a:fillRef>
-            <a:effectRef idx="0">
-              <a:schemeClr val="accent1"/>
-            </a:effectRef>
-            <a:fontRef idx="minor">
-              <a:schemeClr val="lt1"/>
-            </a:fontRef>
-          </p:style>
-          <p:txBody>
-            <a:bodyPr rot="0" spcFirstLastPara="0" vertOverflow="overflow" horzOverflow="overflow" vert="horz" wrap="square" lIns="91440" tIns="45720" rIns="91440" bIns="45720" numCol="1" spcCol="0" rtlCol="0" fromWordArt="0" anchor="ctr" anchorCtr="0" forceAA="0" compatLnSpc="1">
-              <a:prstTxWarp prst="textNoShape">
-                <a:avLst/>
-              </a:prstTxWarp>
-              <a:noAutofit/>
-            </a:bodyPr>
-            <a:lstStyle>
-              <a:defPPr>
-                <a:defRPr lang="ru-RU"/>
-              </a:defPPr>
-            </a:lstStyle>
-            <a:p>
-              <a:pPr algn="ctr" rtl="0"/>
-              <a:endParaRPr lang="ru-RU" dirty="0">
-                <a:latin typeface="Calibri" panose="020F0502020204030204" pitchFamily="34" charset="0"/>
-              </a:endParaRPr>
-            </a:p>
-          </p:txBody>
-        </p:sp>
-        <p:sp>
-          <p:nvSpPr>
-            <p:cNvPr id="7" name="Полилиния 6">
-              <a:extLst>
-                <a:ext uri="{FF2B5EF4-FFF2-40B4-BE49-F238E27FC236}">
-                  <a16:creationId xmlns:a16="http://schemas.microsoft.com/office/drawing/2014/main" id="{A7C6D33A-37B7-D2C4-2C1C-6D5253D0D480}"/>
-                </a:ext>
-              </a:extLst>
-            </p:cNvPr>
-            <p:cNvSpPr>
-              <a:spLocks/>
-            </p:cNvSpPr>
-            <p:nvPr/>
-          </p:nvSpPr>
-          <p:spPr bwMode="auto">
-            <a:xfrm rot="1800000">
-              <a:off x="5243759" y="1430747"/>
-              <a:ext cx="305942" cy="538275"/>
-            </a:xfrm>
-            <a:custGeom>
-              <a:avLst/>
-              <a:gdLst>
-                <a:gd name="T0" fmla="*/ 266 w 266"/>
-                <a:gd name="T1" fmla="*/ 468 h 468"/>
-                <a:gd name="T2" fmla="*/ 0 w 266"/>
-                <a:gd name="T3" fmla="*/ 310 h 468"/>
-                <a:gd name="T4" fmla="*/ 0 w 266"/>
-                <a:gd name="T5" fmla="*/ 310 h 468"/>
-                <a:gd name="T6" fmla="*/ 0 w 266"/>
-                <a:gd name="T7" fmla="*/ 0 h 468"/>
-                <a:gd name="T8" fmla="*/ 0 w 266"/>
-                <a:gd name="T9" fmla="*/ 0 h 468"/>
-                <a:gd name="T10" fmla="*/ 266 w 266"/>
-                <a:gd name="T11" fmla="*/ 159 h 468"/>
-                <a:gd name="T12" fmla="*/ 266 w 266"/>
-                <a:gd name="T13" fmla="*/ 468 h 468"/>
-              </a:gdLst>
-              <a:ahLst/>
-              <a:cxnLst>
-                <a:cxn ang="0">
-                  <a:pos x="T0" y="T1"/>
-                </a:cxn>
-                <a:cxn ang="0">
-                  <a:pos x="T2" y="T3"/>
-                </a:cxn>
-                <a:cxn ang="0">
-                  <a:pos x="T4" y="T5"/>
-                </a:cxn>
-                <a:cxn ang="0">
-                  <a:pos x="T6" y="T7"/>
-                </a:cxn>
-                <a:cxn ang="0">
-                  <a:pos x="T8" y="T9"/>
-                </a:cxn>
-                <a:cxn ang="0">
-                  <a:pos x="T10" y="T11"/>
-                </a:cxn>
-                <a:cxn ang="0">
-                  <a:pos x="T12" y="T13"/>
-                </a:cxn>
-              </a:cxnLst>
-              <a:rect l="0" t="0" r="r" b="b"/>
-              <a:pathLst>
-                <a:path w="266" h="468">
-                  <a:moveTo>
-                    <a:pt x="266" y="468"/>
-                  </a:moveTo>
-                  <a:lnTo>
-                    <a:pt x="0" y="310"/>
-                  </a:lnTo>
-                  <a:lnTo>
-                    <a:pt x="0" y="310"/>
-                  </a:lnTo>
-                  <a:lnTo>
-                    <a:pt x="0" y="0"/>
-                  </a:lnTo>
-                  <a:lnTo>
-                    <a:pt x="0" y="0"/>
-                  </a:lnTo>
-                  <a:lnTo>
-                    <a:pt x="266" y="159"/>
-                  </a:lnTo>
-                  <a:lnTo>
-                    <a:pt x="266" y="468"/>
-                  </a:lnTo>
-                  <a:close/>
-                </a:path>
-              </a:pathLst>
-            </a:custGeom>
-            <a:gradFill flip="none" rotWithShape="1">
-              <a:gsLst>
-                <a:gs pos="20000">
-                  <a:schemeClr val="bg2">
-                    <a:lumMod val="90000"/>
-                    <a:lumOff val="10000"/>
-                    <a:alpha val="20000"/>
-                  </a:schemeClr>
-                </a:gs>
-                <a:gs pos="100000">
-                  <a:schemeClr val="accent1">
-                    <a:lumMod val="60000"/>
-                    <a:lumOff val="40000"/>
-                    <a:alpha val="20000"/>
-                  </a:schemeClr>
-                </a:gs>
-              </a:gsLst>
-              <a:lin ang="19800000" scaled="0"/>
-              <a:tileRect/>
-            </a:gradFill>
-            <a:ln>
-              <a:noFill/>
-            </a:ln>
-            <a:effectLst>
-              <a:innerShdw blurRad="254000">
-                <a:schemeClr val="bg2">
-                  <a:lumMod val="90000"/>
-                  <a:lumOff val="10000"/>
-                </a:schemeClr>
-              </a:innerShdw>
-            </a:effectLst>
-          </p:spPr>
-          <p:style>
-            <a:lnRef idx="2">
-              <a:schemeClr val="accent1">
-                <a:shade val="50000"/>
-              </a:schemeClr>
-            </a:lnRef>
-            <a:fillRef idx="1">
-              <a:schemeClr val="accent1"/>
-            </a:fillRef>
-            <a:effectRef idx="0">
-              <a:schemeClr val="accent1"/>
-            </a:effectRef>
-            <a:fontRef idx="minor">
-              <a:schemeClr val="lt1"/>
-            </a:fontRef>
-          </p:style>
-          <p:txBody>
-            <a:bodyPr rot="0" spcFirstLastPara="0" vertOverflow="overflow" horzOverflow="overflow" vert="horz" wrap="square" lIns="91440" tIns="45720" rIns="91440" bIns="45720" numCol="1" spcCol="0" rtlCol="0" fromWordArt="0" anchor="ctr" anchorCtr="0" forceAA="0" compatLnSpc="1">
-              <a:prstTxWarp prst="textNoShape">
-                <a:avLst/>
-              </a:prstTxWarp>
-              <a:noAutofit/>
-            </a:bodyPr>
-            <a:lstStyle>
-              <a:defPPr>
-                <a:defRPr lang="ru-RU"/>
-              </a:defPPr>
-            </a:lstStyle>
-            <a:p>
-              <a:pPr algn="ctr" rtl="0"/>
-              <a:endParaRPr lang="ru-RU" dirty="0">
-                <a:latin typeface="Calibri" panose="020F0502020204030204" pitchFamily="34" charset="0"/>
-              </a:endParaRPr>
-            </a:p>
-          </p:txBody>
-        </p:sp>
-        <p:sp>
-          <p:nvSpPr>
-            <p:cNvPr id="8" name="Полилиния 8">
-              <a:extLst>
-                <a:ext uri="{FF2B5EF4-FFF2-40B4-BE49-F238E27FC236}">
-                  <a16:creationId xmlns:a16="http://schemas.microsoft.com/office/drawing/2014/main" id="{18145A95-72C3-9BFC-32D2-908F235E389B}"/>
-                </a:ext>
-              </a:extLst>
-            </p:cNvPr>
-            <p:cNvSpPr>
-              <a:spLocks/>
-            </p:cNvSpPr>
-            <p:nvPr/>
-          </p:nvSpPr>
-          <p:spPr bwMode="auto">
-            <a:xfrm rot="1800000">
-              <a:off x="5508097" y="1586019"/>
-              <a:ext cx="315144" cy="538275"/>
-            </a:xfrm>
-            <a:custGeom>
-              <a:avLst/>
-              <a:gdLst>
-                <a:gd name="T0" fmla="*/ 274 w 274"/>
-                <a:gd name="T1" fmla="*/ 0 h 468"/>
-                <a:gd name="T2" fmla="*/ 274 w 274"/>
-                <a:gd name="T3" fmla="*/ 310 h 468"/>
-                <a:gd name="T4" fmla="*/ 274 w 274"/>
-                <a:gd name="T5" fmla="*/ 310 h 468"/>
-                <a:gd name="T6" fmla="*/ 0 w 274"/>
-                <a:gd name="T7" fmla="*/ 468 h 468"/>
-                <a:gd name="T8" fmla="*/ 0 w 274"/>
-                <a:gd name="T9" fmla="*/ 159 h 468"/>
-                <a:gd name="T10" fmla="*/ 274 w 274"/>
-                <a:gd name="T11" fmla="*/ 0 h 468"/>
-                <a:gd name="T12" fmla="*/ 274 w 274"/>
-                <a:gd name="T13" fmla="*/ 0 h 468"/>
-              </a:gdLst>
-              <a:ahLst/>
-              <a:cxnLst>
-                <a:cxn ang="0">
-                  <a:pos x="T0" y="T1"/>
-                </a:cxn>
-                <a:cxn ang="0">
-                  <a:pos x="T2" y="T3"/>
-                </a:cxn>
-                <a:cxn ang="0">
-                  <a:pos x="T4" y="T5"/>
-                </a:cxn>
-                <a:cxn ang="0">
-                  <a:pos x="T6" y="T7"/>
-                </a:cxn>
-                <a:cxn ang="0">
-                  <a:pos x="T8" y="T9"/>
-                </a:cxn>
-                <a:cxn ang="0">
-                  <a:pos x="T10" y="T11"/>
-                </a:cxn>
-                <a:cxn ang="0">
-                  <a:pos x="T12" y="T13"/>
-                </a:cxn>
-              </a:cxnLst>
-              <a:rect l="0" t="0" r="r" b="b"/>
-              <a:pathLst>
-                <a:path w="274" h="468">
-                  <a:moveTo>
-                    <a:pt x="274" y="0"/>
-                  </a:moveTo>
-                  <a:lnTo>
-                    <a:pt x="274" y="310"/>
-                  </a:lnTo>
-                  <a:lnTo>
-                    <a:pt x="274" y="310"/>
-                  </a:lnTo>
-                  <a:lnTo>
-                    <a:pt x="0" y="468"/>
-                  </a:lnTo>
-                  <a:lnTo>
-                    <a:pt x="0" y="159"/>
-                  </a:lnTo>
-                  <a:lnTo>
-                    <a:pt x="274" y="0"/>
-                  </a:lnTo>
-                  <a:lnTo>
-                    <a:pt x="274" y="0"/>
-                  </a:lnTo>
-                  <a:close/>
-                </a:path>
-              </a:pathLst>
-            </a:custGeom>
-            <a:gradFill flip="none" rotWithShape="1">
-              <a:gsLst>
-                <a:gs pos="20000">
-                  <a:schemeClr val="bg2">
-                    <a:lumMod val="90000"/>
-                    <a:lumOff val="10000"/>
-                    <a:alpha val="20000"/>
-                  </a:schemeClr>
-                </a:gs>
-                <a:gs pos="100000">
-                  <a:schemeClr val="accent1">
-                    <a:lumMod val="60000"/>
-                    <a:lumOff val="40000"/>
-                    <a:alpha val="20000"/>
-                  </a:schemeClr>
-                </a:gs>
-              </a:gsLst>
-              <a:lin ang="18000000" scaled="0"/>
-              <a:tileRect/>
-            </a:gradFill>
-            <a:ln>
-              <a:noFill/>
-            </a:ln>
-            <a:effectLst>
-              <a:innerShdw blurRad="254000">
-                <a:schemeClr val="accent1">
-                  <a:lumMod val="60000"/>
-                  <a:lumOff val="40000"/>
-                  <a:alpha val="60000"/>
-                </a:schemeClr>
-              </a:innerShdw>
-            </a:effectLst>
-          </p:spPr>
-          <p:style>
-            <a:lnRef idx="2">
-              <a:schemeClr val="accent1">
-                <a:shade val="50000"/>
-              </a:schemeClr>
-            </a:lnRef>
-            <a:fillRef idx="1">
-              <a:schemeClr val="accent1"/>
-            </a:fillRef>
-            <a:effectRef idx="0">
-              <a:schemeClr val="accent1"/>
-            </a:effectRef>
-            <a:fontRef idx="minor">
-              <a:schemeClr val="lt1"/>
-            </a:fontRef>
-          </p:style>
-          <p:txBody>
-            <a:bodyPr rot="0" spcFirstLastPara="0" vertOverflow="overflow" horzOverflow="overflow" vert="horz" wrap="square" lIns="91440" tIns="45720" rIns="91440" bIns="45720" numCol="1" spcCol="0" rtlCol="0" fromWordArt="0" anchor="ctr" anchorCtr="0" forceAA="0" compatLnSpc="1">
-              <a:prstTxWarp prst="textNoShape">
-                <a:avLst/>
-              </a:prstTxWarp>
-              <a:noAutofit/>
-            </a:bodyPr>
-            <a:lstStyle>
-              <a:defPPr>
-                <a:defRPr lang="ru-RU"/>
-              </a:defPPr>
-            </a:lstStyle>
-            <a:p>
-              <a:pPr algn="ctr" rtl="0"/>
-              <a:endParaRPr lang="ru-RU" dirty="0">
-                <a:latin typeface="Calibri" panose="020F0502020204030204" pitchFamily="34" charset="0"/>
-              </a:endParaRPr>
-            </a:p>
-          </p:txBody>
-        </p:sp>
-      </p:grpSp>
-      <p:sp>
-        <p:nvSpPr>
-          <p:cNvPr id="2" name="Заголовок 1">
-            <a:extLst>
-              <a:ext uri="{FF2B5EF4-FFF2-40B4-BE49-F238E27FC236}">
-                <a16:creationId xmlns:a16="http://schemas.microsoft.com/office/drawing/2014/main" id="{338A15DE-D135-0710-9984-A0A55E960CB0}"/>
-              </a:ext>
-            </a:extLst>
-          </p:cNvPr>
-          <p:cNvSpPr>
-            <a:spLocks noGrp="1"/>
-          </p:cNvSpPr>
-          <p:nvPr>
-            <p:ph type="title"/>
-          </p:nvPr>
-        </p:nvSpPr>
-        <p:spPr>
-          <a:xfrm>
-            <a:off x="600974" y="196900"/>
-            <a:ext cx="4899628" cy="2331490"/>
-          </a:xfrm>
-          <a:noFill/>
-        </p:spPr>
-        <p:txBody>
-          <a:bodyPr rtlCol="0" anchor="b"/>
-          <a:lstStyle>
-            <a:defPPr>
-              <a:defRPr lang="ru-RU"/>
-            </a:defPPr>
-          </a:lstStyle>
-          <a:p>
-            <a:r>
-              <a:rPr lang="ru-RU" b="1" dirty="0"/>
-              <a:t>Заключение и Перспективы</a:t>
-            </a:r>
-          </a:p>
-        </p:txBody>
-      </p:sp>
-      <p:sp>
-        <p:nvSpPr>
-          <p:cNvPr id="3" name="Объект 2">
-            <a:extLst>
-              <a:ext uri="{FF2B5EF4-FFF2-40B4-BE49-F238E27FC236}">
-                <a16:creationId xmlns:a16="http://schemas.microsoft.com/office/drawing/2014/main" id="{ECC8AA23-D8D0-93BE-5C5F-103A750B0D2F}"/>
-              </a:ext>
-            </a:extLst>
-          </p:cNvPr>
-          <p:cNvSpPr>
-            <a:spLocks noGrp="1"/>
-          </p:cNvSpPr>
-          <p:nvPr>
-            <p:ph sz="half" idx="1"/>
-          </p:nvPr>
-        </p:nvSpPr>
-        <p:spPr>
-          <a:xfrm>
-            <a:off x="583162" y="2827209"/>
-            <a:ext cx="4917440" cy="3442144"/>
-          </a:xfrm>
-          <a:noFill/>
-        </p:spPr>
-        <p:txBody>
-          <a:bodyPr vert="horz" lIns="91440" tIns="45720" rIns="91440" bIns="45720" rtlCol="0" anchor="t">
-            <a:normAutofit/>
-          </a:bodyPr>
-          <a:lstStyle>
-            <a:defPPr>
-              <a:defRPr lang="ru-RU"/>
-            </a:defPPr>
-          </a:lstStyle>
-          <a:p>
-            <a:pPr marL="285750" indent="-285750">
-              <a:buFont typeface="Arial" panose="020B0604020202020204" pitchFamily="34" charset="0"/>
-              <a:buChar char="•"/>
-            </a:pPr>
-            <a:r>
-              <a:rPr lang="ru-RU" dirty="0"/>
-              <a:t>Итог: Построен чистый, стабильный и воспроизводимый </a:t>
-            </a:r>
-            <a:r>
-              <a:rPr lang="ru-RU" dirty="0" err="1"/>
-              <a:t>пайплайн</a:t>
-            </a:r>
-            <a:r>
-              <a:rPr lang="ru-RU" dirty="0"/>
-              <a:t>, устойчивый к химическим выбросам.</a:t>
-            </a:r>
-          </a:p>
-          <a:p>
-            <a:pPr marL="285750" indent="-285750">
-              <a:buFont typeface="Arial" panose="020B0604020202020204" pitchFamily="34" charset="0"/>
-              <a:buChar char="•"/>
-            </a:pPr>
-            <a:r>
-              <a:rPr lang="ru-RU" dirty="0"/>
-              <a:t>Что можно улучшить: Внедрение 3D-дескрипторов или </a:t>
-            </a:r>
-            <a:r>
-              <a:rPr lang="ru-RU" dirty="0" err="1"/>
-              <a:t>графовых</a:t>
-            </a:r>
-            <a:r>
-              <a:rPr lang="ru-RU" dirty="0"/>
-              <a:t> нейросетей (GNN) для явного кодирования пространственной изомерии молекул, которую не смогли отловить классические табличные фичи.</a:t>
-            </a:r>
-          </a:p>
-        </p:txBody>
-      </p:sp>
-      <p:pic>
-        <p:nvPicPr>
-          <p:cNvPr id="20" name="Рисунок 19" descr="График крупным планом">
-            <a:extLst>
-              <a:ext uri="{FF2B5EF4-FFF2-40B4-BE49-F238E27FC236}">
-                <a16:creationId xmlns:a16="http://schemas.microsoft.com/office/drawing/2014/main" id="{A7019768-5E2A-F9D1-62D6-EC7C5F0BBEC9}"/>
-              </a:ext>
-            </a:extLst>
-          </p:cNvPr>
-          <p:cNvPicPr>
-            <a:picLocks noGrp="1" noChangeAspect="1"/>
-          </p:cNvPicPr>
-          <p:nvPr>
-            <p:ph type="pic" sz="quarter" idx="13"/>
-          </p:nvPr>
-        </p:nvPicPr>
-        <p:blipFill>
-          <a:blip r:embed="rId3">
-            <a:extLst>
-              <a:ext uri="{28A0092B-C50C-407E-A947-70E740481C1C}">
-                <a14:useLocalDpi xmlns:a14="http://schemas.microsoft.com/office/drawing/2010/main" val="0"/>
-              </a:ext>
-            </a:extLst>
-          </a:blip>
-          <a:srcRect l="9" r="9"/>
-          <a:stretch/>
-        </p:blipFill>
-        <p:spPr>
-          <a:xfrm>
-            <a:off x="6095588" y="0"/>
-            <a:ext cx="6095998" cy="6858000"/>
-          </a:xfrm>
-        </p:spPr>
-      </p:pic>
-    </p:spTree>
-    <p:extLst>
-      <p:ext uri="{BB962C8B-B14F-4D97-AF65-F5344CB8AC3E}">
-        <p14:creationId xmlns:p14="http://schemas.microsoft.com/office/powerpoint/2010/main" val="414523832"/>
-      </p:ext>
-    </p:extLst>
-  </p:cSld>
-  <p:clrMapOvr>
-    <a:masterClrMapping/>
-  </p:clrMapOvr>
-</p:sld>
-</file>
-
-<file path=ppt/slides/slide11.xml><?xml version="1.0" encoding="utf-8"?>
-<p:sld xmlns:a="http://schemas.openxmlformats.org/drawingml/2006/main" xmlns:r="http://schemas.openxmlformats.org/officeDocument/2006/relationships" xmlns:p="http://schemas.openxmlformats.org/presentationml/2006/main">
-  <p:cSld>
-    <p:spTree>
-      <p:nvGrpSpPr>
-        <p:cNvPr id="1" name=""/>
-        <p:cNvGrpSpPr/>
-        <p:nvPr/>
-      </p:nvGrpSpPr>
-      <p:grpSpPr>
-        <a:xfrm>
-          <a:off x="0" y="0"/>
-          <a:ext cx="0" cy="0"/>
-          <a:chOff x="0" y="0"/>
-          <a:chExt cx="0" cy="0"/>
-        </a:xfrm>
-      </p:grpSpPr>
-      <p:sp>
-        <p:nvSpPr>
           <p:cNvPr id="2" name="Заголовок 1">
             <a:extLst>
               <a:ext uri="{FF2B5EF4-FFF2-40B4-BE49-F238E27FC236}">
@@ -14174,8 +13333,8 @@
           </a:p>
         </p:txBody>
       </p:sp>
-      <mc:AlternateContent xmlns:mc="http://schemas.openxmlformats.org/markup-compatibility/2006">
-        <mc:Choice xmlns:a14="http://schemas.microsoft.com/office/drawing/2010/main" Requires="a14">
+      <mc:AlternateContent xmlns:mc="http://schemas.openxmlformats.org/markup-compatibility/2006" xmlns:a14="http://schemas.microsoft.com/office/drawing/2010/main">
+        <mc:Choice Requires="a14">
           <p:sp>
             <p:nvSpPr>
               <p:cNvPr id="18" name="TextBox 17">
@@ -14378,13 +13537,7 @@
                           <a:rPr lang="en-US" sz="1600" i="1">
                             <a:latin typeface="Cambria Math" panose="02040503050406030204" pitchFamily="18" charset="0"/>
                           </a:rPr>
-                          <m:t>𝐶</m:t>
-                        </m:r>
-                        <m:r>
-                          <a:rPr lang="en-US" sz="1600" i="1">
-                            <a:latin typeface="Cambria Math" panose="02040503050406030204" pitchFamily="18" charset="0"/>
-                          </a:rPr>
-                          <m:t>𝐶</m:t>
+                          <m:t>𝐶𝐶</m:t>
                         </m:r>
                       </m:e>
                       <m:sub>
@@ -14438,7 +13591,7 @@
             </p:txBody>
           </p:sp>
         </mc:Choice>
-        <mc:Fallback>
+        <mc:Fallback xmlns="">
           <p:sp>
             <p:nvSpPr>
               <p:cNvPr id="18" name="TextBox 17">
@@ -14483,8 +13636,8 @@
           </p:sp>
         </mc:Fallback>
       </mc:AlternateContent>
-      <mc:AlternateContent xmlns:mc="http://schemas.openxmlformats.org/markup-compatibility/2006">
-        <mc:Choice xmlns:a14="http://schemas.microsoft.com/office/drawing/2010/main" Requires="a14">
+      <mc:AlternateContent xmlns:mc="http://schemas.openxmlformats.org/markup-compatibility/2006" xmlns:a14="http://schemas.microsoft.com/office/drawing/2010/main">
+        <mc:Choice Requires="a14">
           <p:sp>
             <p:nvSpPr>
               <p:cNvPr id="19" name="TextBox 18">
@@ -14677,11 +13830,15 @@
                 <a14:m>
                   <m:oMath xmlns:m="http://schemas.openxmlformats.org/officeDocument/2006/math">
                     <m:r>
-                      <a:rPr lang="en-US" sz="1500" i="1"/>
+                      <a:rPr lang="en-US" sz="1500" i="1">
+                        <a:latin typeface="Cambria Math" panose="02040503050406030204" pitchFamily="18" charset="0"/>
+                      </a:rPr>
                       <m:t>𝑆𝐼</m:t>
                     </m:r>
                     <m:r>
-                      <a:rPr lang="en-US" sz="1500" i="1"/>
+                      <a:rPr lang="en-US" sz="1500" i="1">
+                        <a:latin typeface="Cambria Math" panose="02040503050406030204" pitchFamily="18" charset="0"/>
+                      </a:rPr>
                       <m:t> </m:t>
                     </m:r>
                   </m:oMath>
@@ -14694,7 +13851,7 @@
             </p:txBody>
           </p:sp>
         </mc:Choice>
-        <mc:Fallback>
+        <mc:Fallback xmlns="">
           <p:sp>
             <p:nvSpPr>
               <p:cNvPr id="19" name="TextBox 18">
@@ -15167,15 +14324,7 @@
           <a:solidFill>
             <a:srgbClr val="FFFFFF"/>
           </a:solidFill>
-          <a:extLst>
-            <a:ext uri="{909E8E84-426E-40DD-AFC4-6F175D3DCCD1}">
-              <a14:hiddenFill xmlns:a14="http://schemas.microsoft.com/office/drawing/2010/main">
-                <a:solidFill>
-                  <a:srgbClr val="FFFFFF"/>
-                </a:solidFill>
-              </a14:hiddenFill>
-            </a:ext>
-          </a:extLst>
+          <a:extLst/>
         </p:spPr>
       </p:pic>
       <p:cxnSp>
@@ -15917,37 +15066,32 @@
             <p:ph sz="half" idx="1"/>
           </p:nvPr>
         </p:nvSpPr>
-        <p:spPr/>
+        <p:spPr>
+          <a:xfrm>
+            <a:off x="2664897" y="1182811"/>
+            <a:ext cx="6862203" cy="553746"/>
+          </a:xfrm>
+        </p:spPr>
         <p:txBody>
           <a:bodyPr/>
           <a:lstStyle/>
           <a:p>
-            <a:endParaRPr lang="ru-RU"/>
-          </a:p>
-        </p:txBody>
-      </p:sp>
-      <p:sp>
-        <p:nvSpPr>
-          <p:cNvPr id="8" name="Объект 7">
-            <a:extLst>
-              <a:ext uri="{FF2B5EF4-FFF2-40B4-BE49-F238E27FC236}">
-                <a16:creationId xmlns:a16="http://schemas.microsoft.com/office/drawing/2014/main" id="{A68DB345-B485-4607-A381-30E56F38BCC0}"/>
-              </a:ext>
-            </a:extLst>
-          </p:cNvPr>
-          <p:cNvSpPr>
-            <a:spLocks noGrp="1"/>
-          </p:cNvSpPr>
-          <p:nvPr>
-            <p:ph sz="half" idx="13"/>
-          </p:nvPr>
-        </p:nvSpPr>
-        <p:spPr/>
-        <p:txBody>
-          <a:bodyPr/>
-          <a:lstStyle/>
-          <a:p>
-            <a:endParaRPr lang="ru-RU"/>
+            <a:r>
+              <a:rPr lang="ru-RU" dirty="0" err="1"/>
+              <a:t>Multi‑output</a:t>
+            </a:r>
+            <a:r>
+              <a:rPr lang="ru-RU" dirty="0"/>
+              <a:t> + </a:t>
+            </a:r>
+            <a:r>
+              <a:rPr lang="ru-RU" dirty="0" err="1"/>
+              <a:t>Single‑output</a:t>
+            </a:r>
+            <a:r>
+              <a:rPr lang="ru-RU" dirty="0"/>
+              <a:t> с адаптивным пост‑процессингом</a:t>
+            </a:r>
           </a:p>
         </p:txBody>
       </p:sp>
@@ -15967,12 +15111,343 @@
             <p:ph type="title"/>
           </p:nvPr>
         </p:nvSpPr>
-        <p:spPr/>
+        <p:spPr>
+          <a:xfrm>
+            <a:off x="2340521" y="491857"/>
+            <a:ext cx="7510957" cy="967827"/>
+          </a:xfrm>
+        </p:spPr>
         <p:txBody>
           <a:bodyPr/>
           <a:lstStyle/>
           <a:p>
-            <a:endParaRPr lang="ru-RU"/>
+            <a:r>
+              <a:rPr lang="ru-RU" dirty="0"/>
+              <a:t>Гибридный ансамбль моделей</a:t>
+            </a:r>
+          </a:p>
+        </p:txBody>
+      </p:sp>
+      <p:sp>
+        <p:nvSpPr>
+          <p:cNvPr id="12" name="TextBox 11">
+            <a:extLst>
+              <a:ext uri="{FF2B5EF4-FFF2-40B4-BE49-F238E27FC236}">
+                <a16:creationId xmlns:a16="http://schemas.microsoft.com/office/drawing/2014/main" id="{E40DE7C8-66B3-4427-B884-27763DE511AA}"/>
+              </a:ext>
+            </a:extLst>
+          </p:cNvPr>
+          <p:cNvSpPr txBox="1"/>
+          <p:nvPr/>
+        </p:nvSpPr>
+        <p:spPr>
+          <a:xfrm>
+            <a:off x="982909" y="1603954"/>
+            <a:ext cx="9478164" cy="830997"/>
+          </a:xfrm>
+          <a:prstGeom prst="rect">
+            <a:avLst/>
+          </a:prstGeom>
+          <a:noFill/>
+        </p:spPr>
+        <p:txBody>
+          <a:bodyPr wrap="square" rtlCol="0">
+            <a:spAutoFit/>
+          </a:bodyPr>
+          <a:lstStyle/>
+          <a:p>
+            <a:pPr algn="ctr"/>
+            <a:r>
+              <a:rPr lang="ru-RU" sz="1600" dirty="0"/>
+              <a:t>Замысел: объединить два подхода — </a:t>
+            </a:r>
+            <a:r>
+              <a:rPr lang="ru-RU" sz="1600" dirty="0" err="1"/>
+              <a:t>Multi‑output</a:t>
+            </a:r>
+            <a:r>
+              <a:rPr lang="ru-RU" sz="1600" dirty="0"/>
+              <a:t> (улавливает физическую связь SI = CC50 / IC50) и </a:t>
+            </a:r>
+            <a:r>
+              <a:rPr lang="ru-RU" sz="1600" dirty="0" err="1"/>
+              <a:t>Single‑output</a:t>
+            </a:r>
+            <a:r>
+              <a:rPr lang="ru-RU" sz="1600" dirty="0"/>
+              <a:t> (стабильность и независимая оптимизация) — с автоматическим подбором весов через кросс‑валидацию.</a:t>
+            </a:r>
+          </a:p>
+        </p:txBody>
+      </p:sp>
+      <p:sp>
+        <p:nvSpPr>
+          <p:cNvPr id="15" name="TextBox 14">
+            <a:extLst>
+              <a:ext uri="{FF2B5EF4-FFF2-40B4-BE49-F238E27FC236}">
+                <a16:creationId xmlns:a16="http://schemas.microsoft.com/office/drawing/2014/main" id="{7AE9A628-6724-44C6-9D26-E9702D261B51}"/>
+              </a:ext>
+            </a:extLst>
+          </p:cNvPr>
+          <p:cNvSpPr txBox="1"/>
+          <p:nvPr/>
+        </p:nvSpPr>
+        <p:spPr>
+          <a:xfrm>
+            <a:off x="453005" y="2521059"/>
+            <a:ext cx="11476140" cy="1569660"/>
+          </a:xfrm>
+          <a:prstGeom prst="rect">
+            <a:avLst/>
+          </a:prstGeom>
+          <a:noFill/>
+        </p:spPr>
+        <p:txBody>
+          <a:bodyPr wrap="square" rtlCol="0">
+            <a:spAutoFit/>
+          </a:bodyPr>
+          <a:lstStyle/>
+          <a:p>
+            <a:pPr marL="342900" indent="-342900" algn="just">
+              <a:buAutoNum type="arabicPeriod"/>
+            </a:pPr>
+            <a:r>
+              <a:rPr lang="ru-RU" sz="1600" dirty="0"/>
+              <a:t>210 молекулярных дескрипторов</a:t>
+            </a:r>
+            <a:endParaRPr lang="en-US" sz="1600" dirty="0"/>
+          </a:p>
+          <a:p>
+            <a:pPr marL="342900" indent="-342900" algn="just">
+              <a:buFontTx/>
+              <a:buAutoNum type="arabicPeriod"/>
+            </a:pPr>
+            <a:r>
+              <a:rPr lang="ru-RU" sz="1600" dirty="0"/>
+              <a:t>Предобработка (медиана, </a:t>
+            </a:r>
+            <a:r>
+              <a:rPr lang="en-US" sz="1600" dirty="0"/>
+              <a:t>log-</a:t>
+            </a:r>
+            <a:r>
+              <a:rPr lang="ru-RU" sz="1600" dirty="0" err="1"/>
+              <a:t>трасформация</a:t>
+            </a:r>
+            <a:r>
+              <a:rPr lang="ru-RU" sz="1600" dirty="0"/>
+              <a:t> выбросов</a:t>
+            </a:r>
+            <a:r>
+              <a:rPr lang="en-US" sz="1600" dirty="0"/>
+              <a:t>)</a:t>
+            </a:r>
+          </a:p>
+          <a:p>
+            <a:pPr marL="342900" indent="-342900" algn="just">
+              <a:buFontTx/>
+              <a:buAutoNum type="arabicPeriod"/>
+            </a:pPr>
+            <a:r>
+              <a:rPr lang="en-US" sz="1600" b="1" dirty="0"/>
+              <a:t>Multi‑output (</a:t>
+            </a:r>
+            <a:r>
+              <a:rPr lang="en-US" sz="1600" dirty="0" err="1"/>
+              <a:t>CatBoost</a:t>
+            </a:r>
+            <a:r>
+              <a:rPr lang="en-US" sz="1600" dirty="0"/>
+              <a:t>, </a:t>
+            </a:r>
+            <a:r>
+              <a:rPr lang="en-US" sz="1600" dirty="0" err="1"/>
+              <a:t>MultiRMSE</a:t>
+            </a:r>
+            <a:r>
+              <a:rPr lang="en-US" sz="1600" dirty="0"/>
+              <a:t>, </a:t>
+            </a:r>
+            <a:r>
+              <a:rPr lang="ru-RU" sz="1600" dirty="0"/>
+              <a:t>Вес 70%</a:t>
+            </a:r>
+            <a:r>
+              <a:rPr lang="en-US" sz="1600" dirty="0"/>
+              <a:t>)</a:t>
+            </a:r>
+            <a:r>
+              <a:rPr lang="ru-RU" sz="1600" dirty="0"/>
+              <a:t> + </a:t>
+            </a:r>
+            <a:r>
+              <a:rPr lang="en-US" sz="1600" b="1" dirty="0"/>
+              <a:t>Single‑output ×3 (</a:t>
+            </a:r>
+            <a:r>
+              <a:rPr lang="en-US" sz="1600" dirty="0" err="1"/>
+              <a:t>CatBoost</a:t>
+            </a:r>
+            <a:r>
+              <a:rPr lang="en-US" sz="1600" dirty="0"/>
+              <a:t> × 3 seeds, RMSE, </a:t>
+            </a:r>
+            <a:r>
+              <a:rPr lang="ru-RU" sz="1600" dirty="0"/>
+              <a:t>Вес 30%)</a:t>
+            </a:r>
+          </a:p>
+          <a:p>
+            <a:pPr marL="342900" indent="-342900" algn="just">
+              <a:buFontTx/>
+              <a:buAutoNum type="arabicPeriod"/>
+            </a:pPr>
+            <a:r>
+              <a:rPr lang="ru-RU" sz="1600" dirty="0"/>
+              <a:t>Взвешенное усреднение (5‑fold CV)</a:t>
+            </a:r>
+          </a:p>
+          <a:p>
+            <a:pPr marL="342900" indent="-342900" algn="just">
+              <a:buFontTx/>
+              <a:buAutoNum type="arabicPeriod"/>
+            </a:pPr>
+            <a:r>
+              <a:rPr lang="ru-RU" sz="1600" dirty="0"/>
+              <a:t>Пост‑процессинг (</a:t>
+            </a:r>
+            <a:r>
+              <a:rPr lang="ru-RU" sz="1600" dirty="0" err="1"/>
+              <a:t>clip</a:t>
+            </a:r>
+            <a:r>
+              <a:rPr lang="ru-RU" sz="1600" dirty="0"/>
+              <a:t> + адаптивная коррекция SI)</a:t>
+            </a:r>
+          </a:p>
+          <a:p>
+            <a:pPr marL="342900" indent="-342900" algn="just">
+              <a:buFontTx/>
+              <a:buAutoNum type="arabicPeriod"/>
+            </a:pPr>
+            <a:r>
+              <a:rPr lang="ru-RU" sz="1600" dirty="0"/>
+              <a:t>Финальные предсказания IC50, CC50, SI</a:t>
+            </a:r>
+          </a:p>
+        </p:txBody>
+      </p:sp>
+      <p:sp>
+        <p:nvSpPr>
+          <p:cNvPr id="16" name="TextBox 15">
+            <a:extLst>
+              <a:ext uri="{FF2B5EF4-FFF2-40B4-BE49-F238E27FC236}">
+                <a16:creationId xmlns:a16="http://schemas.microsoft.com/office/drawing/2014/main" id="{E282603E-E8E1-4A90-92F3-7FE6B9D7F706}"/>
+              </a:ext>
+            </a:extLst>
+          </p:cNvPr>
+          <p:cNvSpPr txBox="1"/>
+          <p:nvPr/>
+        </p:nvSpPr>
+        <p:spPr>
+          <a:xfrm>
+            <a:off x="3833769" y="4328719"/>
+            <a:ext cx="8358231" cy="1569660"/>
+          </a:xfrm>
+          <a:prstGeom prst="rect">
+            <a:avLst/>
+          </a:prstGeom>
+          <a:noFill/>
+        </p:spPr>
+        <p:txBody>
+          <a:bodyPr wrap="square" rtlCol="0">
+            <a:spAutoFit/>
+          </a:bodyPr>
+          <a:lstStyle/>
+          <a:p>
+            <a:r>
+              <a:rPr lang="ru-RU" sz="1600" b="1" dirty="0"/>
+              <a:t>Ключевые решения:</a:t>
+            </a:r>
+          </a:p>
+          <a:p>
+            <a:r>
+              <a:rPr lang="ru-RU" sz="1600" b="1" dirty="0"/>
+              <a:t>Логарифмирование </a:t>
+            </a:r>
+            <a:r>
+              <a:rPr lang="ru-RU" sz="1600" b="1" dirty="0" err="1"/>
+              <a:t>таргетов</a:t>
+            </a:r>
+            <a:r>
+              <a:rPr lang="ru-RU" sz="1600" dirty="0"/>
+              <a:t> — нормализация скошенного распределения</a:t>
+            </a:r>
+          </a:p>
+          <a:p>
+            <a:r>
+              <a:rPr lang="en-US" sz="1600" b="1" dirty="0"/>
+              <a:t>Log</a:t>
+            </a:r>
+            <a:r>
+              <a:rPr lang="ru-RU" sz="1600" b="1" dirty="0"/>
+              <a:t>‑трансформация </a:t>
+            </a:r>
+            <a:r>
+              <a:rPr lang="ru-RU" sz="1600" dirty="0"/>
+              <a:t>выбросов в признаках (</a:t>
+            </a:r>
+            <a:r>
+              <a:rPr lang="ru-RU" sz="1600" dirty="0" err="1"/>
+              <a:t>max</a:t>
+            </a:r>
+            <a:r>
+              <a:rPr lang="ru-RU" sz="1600" dirty="0"/>
+              <a:t> &gt; 10000)</a:t>
+            </a:r>
+            <a:endParaRPr lang="en-US" sz="1600" dirty="0"/>
+          </a:p>
+          <a:p>
+            <a:r>
+              <a:rPr lang="ru-RU" sz="1600" b="1" dirty="0" err="1"/>
+              <a:t>MultiRMSE</a:t>
+            </a:r>
+            <a:r>
+              <a:rPr lang="ru-RU" sz="1600" b="1" dirty="0"/>
+              <a:t> </a:t>
+            </a:r>
+            <a:r>
+              <a:rPr lang="ru-RU" sz="1600" b="1" dirty="0" err="1"/>
+              <a:t>loss</a:t>
+            </a:r>
+            <a:r>
+              <a:rPr lang="ru-RU" sz="1600" dirty="0"/>
+              <a:t> — учёт связи между IC50, CC50 и SI</a:t>
+            </a:r>
+          </a:p>
+          <a:p>
+            <a:r>
+              <a:rPr lang="ru-RU" sz="1600" b="1" dirty="0"/>
+              <a:t>Ансамбль из 3 </a:t>
+            </a:r>
+            <a:r>
+              <a:rPr lang="ru-RU" sz="1600" b="1" dirty="0" err="1"/>
+              <a:t>seed</a:t>
+            </a:r>
+            <a:r>
+              <a:rPr lang="ru-RU" sz="1600" dirty="0"/>
+              <a:t> — снижение дисперсии</a:t>
+            </a:r>
+          </a:p>
+          <a:p>
+            <a:r>
+              <a:rPr lang="ru-RU" sz="1600" b="1" dirty="0"/>
+              <a:t>Адаптивная коррекция SI</a:t>
+            </a:r>
+            <a:r>
+              <a:rPr lang="ru-RU" sz="1600" dirty="0"/>
+              <a:t> — исправление физических несоответствий</a:t>
+            </a:r>
           </a:p>
         </p:txBody>
       </p:sp>
@@ -15990,111 +15465,6 @@
 </file>
 
 <file path=ppt/slides/slide8.xml><?xml version="1.0" encoding="utf-8"?>
-<p:sld xmlns:a="http://schemas.openxmlformats.org/drawingml/2006/main" xmlns:r="http://schemas.openxmlformats.org/officeDocument/2006/relationships" xmlns:p="http://schemas.openxmlformats.org/presentationml/2006/main">
-  <p:cSld>
-    <p:spTree>
-      <p:nvGrpSpPr>
-        <p:cNvPr id="1" name=""/>
-        <p:cNvGrpSpPr/>
-        <p:nvPr/>
-      </p:nvGrpSpPr>
-      <p:grpSpPr>
-        <a:xfrm>
-          <a:off x="0" y="0"/>
-          <a:ext cx="0" cy="0"/>
-          <a:chOff x="0" y="0"/>
-          <a:chExt cx="0" cy="0"/>
-        </a:xfrm>
-      </p:grpSpPr>
-      <p:sp>
-        <p:nvSpPr>
-          <p:cNvPr id="4" name="Заголовок 3">
-            <a:extLst>
-              <a:ext uri="{FF2B5EF4-FFF2-40B4-BE49-F238E27FC236}">
-                <a16:creationId xmlns:a16="http://schemas.microsoft.com/office/drawing/2014/main" id="{E9F4D25B-BCFF-4A10-8A22-0EF11F32147A}"/>
-              </a:ext>
-            </a:extLst>
-          </p:cNvPr>
-          <p:cNvSpPr>
-            <a:spLocks noGrp="1"/>
-          </p:cNvSpPr>
-          <p:nvPr>
-            <p:ph type="title"/>
-          </p:nvPr>
-        </p:nvSpPr>
-        <p:spPr/>
-        <p:txBody>
-          <a:bodyPr/>
-          <a:lstStyle/>
-          <a:p>
-            <a:endParaRPr lang="ru-RU"/>
-          </a:p>
-        </p:txBody>
-      </p:sp>
-      <p:sp>
-        <p:nvSpPr>
-          <p:cNvPr id="8" name="Объект 7">
-            <a:extLst>
-              <a:ext uri="{FF2B5EF4-FFF2-40B4-BE49-F238E27FC236}">
-                <a16:creationId xmlns:a16="http://schemas.microsoft.com/office/drawing/2014/main" id="{51935DEC-94AD-4EE7-AA5C-7FE44D12D7F8}"/>
-              </a:ext>
-            </a:extLst>
-          </p:cNvPr>
-          <p:cNvSpPr>
-            <a:spLocks noGrp="1"/>
-          </p:cNvSpPr>
-          <p:nvPr>
-            <p:ph sz="half" idx="1"/>
-          </p:nvPr>
-        </p:nvSpPr>
-        <p:spPr/>
-        <p:txBody>
-          <a:bodyPr/>
-          <a:lstStyle/>
-          <a:p>
-            <a:endParaRPr lang="ru-RU"/>
-          </a:p>
-        </p:txBody>
-      </p:sp>
-      <p:sp>
-        <p:nvSpPr>
-          <p:cNvPr id="10" name="Объект 9">
-            <a:extLst>
-              <a:ext uri="{FF2B5EF4-FFF2-40B4-BE49-F238E27FC236}">
-                <a16:creationId xmlns:a16="http://schemas.microsoft.com/office/drawing/2014/main" id="{C14B247D-37AE-497B-8AE9-EFE308BE2955}"/>
-              </a:ext>
-            </a:extLst>
-          </p:cNvPr>
-          <p:cNvSpPr>
-            <a:spLocks noGrp="1"/>
-          </p:cNvSpPr>
-          <p:nvPr>
-            <p:ph sz="half" idx="13"/>
-          </p:nvPr>
-        </p:nvSpPr>
-        <p:spPr/>
-        <p:txBody>
-          <a:bodyPr/>
-          <a:lstStyle/>
-          <a:p>
-            <a:endParaRPr lang="ru-RU"/>
-          </a:p>
-        </p:txBody>
-      </p:sp>
-    </p:spTree>
-    <p:extLst>
-      <p:ext uri="{BB962C8B-B14F-4D97-AF65-F5344CB8AC3E}">
-        <p14:creationId xmlns:p14="http://schemas.microsoft.com/office/powerpoint/2010/main" val="3353460760"/>
-      </p:ext>
-    </p:extLst>
-  </p:cSld>
-  <p:clrMapOvr>
-    <a:masterClrMapping/>
-  </p:clrMapOvr>
-</p:sld>
-</file>
-
-<file path=ppt/slides/slide9.xml><?xml version="1.0" encoding="utf-8"?>
 <p:sld xmlns:a="http://schemas.openxmlformats.org/drawingml/2006/main" xmlns:r="http://schemas.openxmlformats.org/officeDocument/2006/relationships" xmlns:p="http://schemas.openxmlformats.org/presentationml/2006/main">
   <p:cSld>
     <p:spTree>
@@ -16291,7 +15661,7 @@
                     <a:lstStyle/>
                     <a:p>
                       <a:r>
-                        <a:rPr lang="en-US">
+                        <a:rPr lang="en-US" dirty="0">
                           <a:effectLst/>
                         </a:rPr>
                         <a:t>IC50</a:t>
@@ -16627,6 +15997,752 @@
     <p:extLst>
       <p:ext uri="{BB962C8B-B14F-4D97-AF65-F5344CB8AC3E}">
         <p14:creationId xmlns:p14="http://schemas.microsoft.com/office/powerpoint/2010/main" val="314440392"/>
+      </p:ext>
+    </p:extLst>
+  </p:cSld>
+  <p:clrMapOvr>
+    <a:masterClrMapping/>
+  </p:clrMapOvr>
+</p:sld>
+</file>
+
+<file path=ppt/slides/slide9.xml><?xml version="1.0" encoding="utf-8"?>
+<p:sld xmlns:a="http://schemas.openxmlformats.org/drawingml/2006/main" xmlns:r="http://schemas.openxmlformats.org/officeDocument/2006/relationships" xmlns:p="http://schemas.openxmlformats.org/presentationml/2006/main">
+  <p:cSld>
+    <p:spTree>
+      <p:nvGrpSpPr>
+        <p:cNvPr id="1" name=""/>
+        <p:cNvGrpSpPr/>
+        <p:nvPr/>
+      </p:nvGrpSpPr>
+      <p:grpSpPr>
+        <a:xfrm>
+          <a:off x="0" y="0"/>
+          <a:ext cx="0" cy="0"/>
+          <a:chOff x="0" y="0"/>
+          <a:chExt cx="0" cy="0"/>
+        </a:xfrm>
+      </p:grpSpPr>
+      <p:sp>
+        <p:nvSpPr>
+          <p:cNvPr id="9" name="Овал 8">
+            <a:extLst>
+              <a:ext uri="{FF2B5EF4-FFF2-40B4-BE49-F238E27FC236}">
+                <a16:creationId xmlns:a16="http://schemas.microsoft.com/office/drawing/2014/main" id="{5C4A7DC2-42C3-FDDF-02BF-9598D75A6A83}"/>
+              </a:ext>
+              <a:ext uri="{C183D7F6-B498-43B3-948B-1728B52AA6E4}">
+                <adec:decorative xmlns:adec="http://schemas.microsoft.com/office/drawing/2017/decorative" val="1"/>
+              </a:ext>
+            </a:extLst>
+          </p:cNvPr>
+          <p:cNvSpPr>
+            <a:spLocks noChangeAspect="1"/>
+          </p:cNvSpPr>
+          <p:nvPr/>
+        </p:nvSpPr>
+        <p:spPr>
+          <a:xfrm>
+            <a:off x="1189378" y="5232629"/>
+            <a:ext cx="1080000" cy="1080000"/>
+          </a:xfrm>
+          <a:prstGeom prst="ellipse">
+            <a:avLst/>
+          </a:prstGeom>
+          <a:gradFill flip="none" rotWithShape="1">
+            <a:gsLst>
+              <a:gs pos="100000">
+                <a:schemeClr val="bg2">
+                  <a:lumMod val="50000"/>
+                  <a:lumOff val="50000"/>
+                </a:schemeClr>
+              </a:gs>
+              <a:gs pos="60000">
+                <a:schemeClr val="bg2">
+                  <a:lumMod val="100000"/>
+                </a:schemeClr>
+              </a:gs>
+            </a:gsLst>
+            <a:path path="circle">
+              <a:fillToRect l="100000" b="100000"/>
+            </a:path>
+            <a:tileRect t="-100000" r="-100000"/>
+          </a:gradFill>
+          <a:ln>
+            <a:noFill/>
+          </a:ln>
+          <a:effectLst>
+            <a:innerShdw blurRad="254000" dist="127000" dir="2700000">
+              <a:schemeClr val="accent1">
+                <a:lumMod val="60000"/>
+                <a:lumOff val="40000"/>
+                <a:alpha val="40000"/>
+              </a:schemeClr>
+            </a:innerShdw>
+            <a:softEdge rad="0"/>
+          </a:effectLst>
+        </p:spPr>
+        <p:style>
+          <a:lnRef idx="2">
+            <a:schemeClr val="accent1">
+              <a:shade val="50000"/>
+            </a:schemeClr>
+          </a:lnRef>
+          <a:fillRef idx="1">
+            <a:schemeClr val="accent1"/>
+          </a:fillRef>
+          <a:effectRef idx="0">
+            <a:schemeClr val="accent1"/>
+          </a:effectRef>
+          <a:fontRef idx="minor">
+            <a:schemeClr val="lt1"/>
+          </a:fontRef>
+        </p:style>
+        <p:txBody>
+          <a:bodyPr rot="0" spcFirstLastPara="0" vertOverflow="overflow" horzOverflow="overflow" vert="horz" wrap="square" lIns="91440" tIns="45720" rIns="91440" bIns="45720" numCol="1" spcCol="0" rtlCol="0" fromWordArt="0" anchor="ctr" anchorCtr="0" forceAA="0" compatLnSpc="1">
+            <a:prstTxWarp prst="textNoShape">
+              <a:avLst/>
+            </a:prstTxWarp>
+            <a:noAutofit/>
+          </a:bodyPr>
+          <a:lstStyle>
+            <a:defPPr>
+              <a:defRPr lang="ru-RU"/>
+            </a:defPPr>
+          </a:lstStyle>
+          <a:p>
+            <a:pPr algn="ctr" rtl="0"/>
+            <a:endParaRPr lang="ru-RU" dirty="0">
+              <a:latin typeface="Calibri" panose="020F0502020204030204" pitchFamily="34" charset="0"/>
+            </a:endParaRPr>
+          </a:p>
+        </p:txBody>
+      </p:sp>
+      <p:grpSp>
+        <p:nvGrpSpPr>
+          <p:cNvPr id="4" name="Группа 3">
+            <a:extLst>
+              <a:ext uri="{FF2B5EF4-FFF2-40B4-BE49-F238E27FC236}">
+                <a16:creationId xmlns:a16="http://schemas.microsoft.com/office/drawing/2014/main" id="{21106B59-80B8-CEED-0BCA-BC3F80A85FEA}"/>
+              </a:ext>
+              <a:ext uri="{C183D7F6-B498-43B3-948B-1728B52AA6E4}">
+                <adec:decorative xmlns:adec="http://schemas.microsoft.com/office/drawing/2017/decorative" val="1"/>
+              </a:ext>
+            </a:extLst>
+          </p:cNvPr>
+          <p:cNvGrpSpPr/>
+          <p:nvPr/>
+        </p:nvGrpSpPr>
+        <p:grpSpPr>
+          <a:xfrm>
+            <a:off x="4803321" y="682622"/>
+            <a:ext cx="734257" cy="760506"/>
+            <a:chOff x="5243759" y="1363788"/>
+            <a:chExt cx="734257" cy="760506"/>
+          </a:xfrm>
+        </p:grpSpPr>
+        <p:sp>
+          <p:nvSpPr>
+            <p:cNvPr id="6" name="Полилиния 5">
+              <a:extLst>
+                <a:ext uri="{FF2B5EF4-FFF2-40B4-BE49-F238E27FC236}">
+                  <a16:creationId xmlns:a16="http://schemas.microsoft.com/office/drawing/2014/main" id="{73C2F317-81E4-3678-2FF2-495B3A95470A}"/>
+                </a:ext>
+              </a:extLst>
+            </p:cNvPr>
+            <p:cNvSpPr>
+              <a:spLocks/>
+            </p:cNvSpPr>
+            <p:nvPr/>
+          </p:nvSpPr>
+          <p:spPr bwMode="auto">
+            <a:xfrm rot="1800000">
+              <a:off x="5356930" y="1363788"/>
+              <a:ext cx="621086" cy="364601"/>
+            </a:xfrm>
+            <a:custGeom>
+              <a:avLst/>
+              <a:gdLst>
+                <a:gd name="T0" fmla="*/ 266 w 540"/>
+                <a:gd name="T1" fmla="*/ 0 h 317"/>
+                <a:gd name="T2" fmla="*/ 0 w 540"/>
+                <a:gd name="T3" fmla="*/ 158 h 317"/>
+                <a:gd name="T4" fmla="*/ 266 w 540"/>
+                <a:gd name="T5" fmla="*/ 317 h 317"/>
+                <a:gd name="T6" fmla="*/ 540 w 540"/>
+                <a:gd name="T7" fmla="*/ 158 h 317"/>
+                <a:gd name="T8" fmla="*/ 266 w 540"/>
+                <a:gd name="T9" fmla="*/ 0 h 317"/>
+              </a:gdLst>
+              <a:ahLst/>
+              <a:cxnLst>
+                <a:cxn ang="0">
+                  <a:pos x="T0" y="T1"/>
+                </a:cxn>
+                <a:cxn ang="0">
+                  <a:pos x="T2" y="T3"/>
+                </a:cxn>
+                <a:cxn ang="0">
+                  <a:pos x="T4" y="T5"/>
+                </a:cxn>
+                <a:cxn ang="0">
+                  <a:pos x="T6" y="T7"/>
+                </a:cxn>
+                <a:cxn ang="0">
+                  <a:pos x="T8" y="T9"/>
+                </a:cxn>
+              </a:cxnLst>
+              <a:rect l="0" t="0" r="r" b="b"/>
+              <a:pathLst>
+                <a:path w="540" h="317">
+                  <a:moveTo>
+                    <a:pt x="266" y="0"/>
+                  </a:moveTo>
+                  <a:lnTo>
+                    <a:pt x="0" y="158"/>
+                  </a:lnTo>
+                  <a:lnTo>
+                    <a:pt x="266" y="317"/>
+                  </a:lnTo>
+                  <a:lnTo>
+                    <a:pt x="540" y="158"/>
+                  </a:lnTo>
+                  <a:lnTo>
+                    <a:pt x="266" y="0"/>
+                  </a:lnTo>
+                  <a:close/>
+                </a:path>
+              </a:pathLst>
+            </a:custGeom>
+            <a:gradFill flip="none" rotWithShape="1">
+              <a:gsLst>
+                <a:gs pos="20000">
+                  <a:schemeClr val="bg2">
+                    <a:lumMod val="90000"/>
+                    <a:lumOff val="10000"/>
+                    <a:alpha val="20000"/>
+                  </a:schemeClr>
+                </a:gs>
+                <a:gs pos="100000">
+                  <a:schemeClr val="accent1">
+                    <a:lumMod val="60000"/>
+                    <a:lumOff val="40000"/>
+                    <a:alpha val="20000"/>
+                  </a:schemeClr>
+                </a:gs>
+              </a:gsLst>
+              <a:lin ang="0" scaled="0"/>
+              <a:tileRect/>
+            </a:gradFill>
+            <a:ln>
+              <a:noFill/>
+            </a:ln>
+            <a:effectLst>
+              <a:innerShdw blurRad="254000">
+                <a:schemeClr val="bg2">
+                  <a:lumMod val="90000"/>
+                  <a:lumOff val="10000"/>
+                </a:schemeClr>
+              </a:innerShdw>
+            </a:effectLst>
+          </p:spPr>
+          <p:style>
+            <a:lnRef idx="2">
+              <a:schemeClr val="accent1">
+                <a:shade val="50000"/>
+              </a:schemeClr>
+            </a:lnRef>
+            <a:fillRef idx="1">
+              <a:schemeClr val="accent1"/>
+            </a:fillRef>
+            <a:effectRef idx="0">
+              <a:schemeClr val="accent1"/>
+            </a:effectRef>
+            <a:fontRef idx="minor">
+              <a:schemeClr val="lt1"/>
+            </a:fontRef>
+          </p:style>
+          <p:txBody>
+            <a:bodyPr rot="0" spcFirstLastPara="0" vertOverflow="overflow" horzOverflow="overflow" vert="horz" wrap="square" lIns="91440" tIns="45720" rIns="91440" bIns="45720" numCol="1" spcCol="0" rtlCol="0" fromWordArt="0" anchor="ctr" anchorCtr="0" forceAA="0" compatLnSpc="1">
+              <a:prstTxWarp prst="textNoShape">
+                <a:avLst/>
+              </a:prstTxWarp>
+              <a:noAutofit/>
+            </a:bodyPr>
+            <a:lstStyle>
+              <a:defPPr>
+                <a:defRPr lang="ru-RU"/>
+              </a:defPPr>
+            </a:lstStyle>
+            <a:p>
+              <a:pPr algn="ctr" rtl="0"/>
+              <a:endParaRPr lang="ru-RU" dirty="0">
+                <a:latin typeface="Calibri" panose="020F0502020204030204" pitchFamily="34" charset="0"/>
+              </a:endParaRPr>
+            </a:p>
+          </p:txBody>
+        </p:sp>
+        <p:sp>
+          <p:nvSpPr>
+            <p:cNvPr id="7" name="Полилиния 6">
+              <a:extLst>
+                <a:ext uri="{FF2B5EF4-FFF2-40B4-BE49-F238E27FC236}">
+                  <a16:creationId xmlns:a16="http://schemas.microsoft.com/office/drawing/2014/main" id="{A7C6D33A-37B7-D2C4-2C1C-6D5253D0D480}"/>
+                </a:ext>
+              </a:extLst>
+            </p:cNvPr>
+            <p:cNvSpPr>
+              <a:spLocks/>
+            </p:cNvSpPr>
+            <p:nvPr/>
+          </p:nvSpPr>
+          <p:spPr bwMode="auto">
+            <a:xfrm rot="1800000">
+              <a:off x="5243759" y="1430747"/>
+              <a:ext cx="305942" cy="538275"/>
+            </a:xfrm>
+            <a:custGeom>
+              <a:avLst/>
+              <a:gdLst>
+                <a:gd name="T0" fmla="*/ 266 w 266"/>
+                <a:gd name="T1" fmla="*/ 468 h 468"/>
+                <a:gd name="T2" fmla="*/ 0 w 266"/>
+                <a:gd name="T3" fmla="*/ 310 h 468"/>
+                <a:gd name="T4" fmla="*/ 0 w 266"/>
+                <a:gd name="T5" fmla="*/ 310 h 468"/>
+                <a:gd name="T6" fmla="*/ 0 w 266"/>
+                <a:gd name="T7" fmla="*/ 0 h 468"/>
+                <a:gd name="T8" fmla="*/ 0 w 266"/>
+                <a:gd name="T9" fmla="*/ 0 h 468"/>
+                <a:gd name="T10" fmla="*/ 266 w 266"/>
+                <a:gd name="T11" fmla="*/ 159 h 468"/>
+                <a:gd name="T12" fmla="*/ 266 w 266"/>
+                <a:gd name="T13" fmla="*/ 468 h 468"/>
+              </a:gdLst>
+              <a:ahLst/>
+              <a:cxnLst>
+                <a:cxn ang="0">
+                  <a:pos x="T0" y="T1"/>
+                </a:cxn>
+                <a:cxn ang="0">
+                  <a:pos x="T2" y="T3"/>
+                </a:cxn>
+                <a:cxn ang="0">
+                  <a:pos x="T4" y="T5"/>
+                </a:cxn>
+                <a:cxn ang="0">
+                  <a:pos x="T6" y="T7"/>
+                </a:cxn>
+                <a:cxn ang="0">
+                  <a:pos x="T8" y="T9"/>
+                </a:cxn>
+                <a:cxn ang="0">
+                  <a:pos x="T10" y="T11"/>
+                </a:cxn>
+                <a:cxn ang="0">
+                  <a:pos x="T12" y="T13"/>
+                </a:cxn>
+              </a:cxnLst>
+              <a:rect l="0" t="0" r="r" b="b"/>
+              <a:pathLst>
+                <a:path w="266" h="468">
+                  <a:moveTo>
+                    <a:pt x="266" y="468"/>
+                  </a:moveTo>
+                  <a:lnTo>
+                    <a:pt x="0" y="310"/>
+                  </a:lnTo>
+                  <a:lnTo>
+                    <a:pt x="0" y="310"/>
+                  </a:lnTo>
+                  <a:lnTo>
+                    <a:pt x="0" y="0"/>
+                  </a:lnTo>
+                  <a:lnTo>
+                    <a:pt x="0" y="0"/>
+                  </a:lnTo>
+                  <a:lnTo>
+                    <a:pt x="266" y="159"/>
+                  </a:lnTo>
+                  <a:lnTo>
+                    <a:pt x="266" y="468"/>
+                  </a:lnTo>
+                  <a:close/>
+                </a:path>
+              </a:pathLst>
+            </a:custGeom>
+            <a:gradFill flip="none" rotWithShape="1">
+              <a:gsLst>
+                <a:gs pos="20000">
+                  <a:schemeClr val="bg2">
+                    <a:lumMod val="90000"/>
+                    <a:lumOff val="10000"/>
+                    <a:alpha val="20000"/>
+                  </a:schemeClr>
+                </a:gs>
+                <a:gs pos="100000">
+                  <a:schemeClr val="accent1">
+                    <a:lumMod val="60000"/>
+                    <a:lumOff val="40000"/>
+                    <a:alpha val="20000"/>
+                  </a:schemeClr>
+                </a:gs>
+              </a:gsLst>
+              <a:lin ang="19800000" scaled="0"/>
+              <a:tileRect/>
+            </a:gradFill>
+            <a:ln>
+              <a:noFill/>
+            </a:ln>
+            <a:effectLst>
+              <a:innerShdw blurRad="254000">
+                <a:schemeClr val="bg2">
+                  <a:lumMod val="90000"/>
+                  <a:lumOff val="10000"/>
+                </a:schemeClr>
+              </a:innerShdw>
+            </a:effectLst>
+          </p:spPr>
+          <p:style>
+            <a:lnRef idx="2">
+              <a:schemeClr val="accent1">
+                <a:shade val="50000"/>
+              </a:schemeClr>
+            </a:lnRef>
+            <a:fillRef idx="1">
+              <a:schemeClr val="accent1"/>
+            </a:fillRef>
+            <a:effectRef idx="0">
+              <a:schemeClr val="accent1"/>
+            </a:effectRef>
+            <a:fontRef idx="minor">
+              <a:schemeClr val="lt1"/>
+            </a:fontRef>
+          </p:style>
+          <p:txBody>
+            <a:bodyPr rot="0" spcFirstLastPara="0" vertOverflow="overflow" horzOverflow="overflow" vert="horz" wrap="square" lIns="91440" tIns="45720" rIns="91440" bIns="45720" numCol="1" spcCol="0" rtlCol="0" fromWordArt="0" anchor="ctr" anchorCtr="0" forceAA="0" compatLnSpc="1">
+              <a:prstTxWarp prst="textNoShape">
+                <a:avLst/>
+              </a:prstTxWarp>
+              <a:noAutofit/>
+            </a:bodyPr>
+            <a:lstStyle>
+              <a:defPPr>
+                <a:defRPr lang="ru-RU"/>
+              </a:defPPr>
+            </a:lstStyle>
+            <a:p>
+              <a:pPr algn="ctr" rtl="0"/>
+              <a:endParaRPr lang="ru-RU" dirty="0">
+                <a:latin typeface="Calibri" panose="020F0502020204030204" pitchFamily="34" charset="0"/>
+              </a:endParaRPr>
+            </a:p>
+          </p:txBody>
+        </p:sp>
+        <p:sp>
+          <p:nvSpPr>
+            <p:cNvPr id="8" name="Полилиния 8">
+              <a:extLst>
+                <a:ext uri="{FF2B5EF4-FFF2-40B4-BE49-F238E27FC236}">
+                  <a16:creationId xmlns:a16="http://schemas.microsoft.com/office/drawing/2014/main" id="{18145A95-72C3-9BFC-32D2-908F235E389B}"/>
+                </a:ext>
+              </a:extLst>
+            </p:cNvPr>
+            <p:cNvSpPr>
+              <a:spLocks/>
+            </p:cNvSpPr>
+            <p:nvPr/>
+          </p:nvSpPr>
+          <p:spPr bwMode="auto">
+            <a:xfrm rot="1800000">
+              <a:off x="5508097" y="1586019"/>
+              <a:ext cx="315144" cy="538275"/>
+            </a:xfrm>
+            <a:custGeom>
+              <a:avLst/>
+              <a:gdLst>
+                <a:gd name="T0" fmla="*/ 274 w 274"/>
+                <a:gd name="T1" fmla="*/ 0 h 468"/>
+                <a:gd name="T2" fmla="*/ 274 w 274"/>
+                <a:gd name="T3" fmla="*/ 310 h 468"/>
+                <a:gd name="T4" fmla="*/ 274 w 274"/>
+                <a:gd name="T5" fmla="*/ 310 h 468"/>
+                <a:gd name="T6" fmla="*/ 0 w 274"/>
+                <a:gd name="T7" fmla="*/ 468 h 468"/>
+                <a:gd name="T8" fmla="*/ 0 w 274"/>
+                <a:gd name="T9" fmla="*/ 159 h 468"/>
+                <a:gd name="T10" fmla="*/ 274 w 274"/>
+                <a:gd name="T11" fmla="*/ 0 h 468"/>
+                <a:gd name="T12" fmla="*/ 274 w 274"/>
+                <a:gd name="T13" fmla="*/ 0 h 468"/>
+              </a:gdLst>
+              <a:ahLst/>
+              <a:cxnLst>
+                <a:cxn ang="0">
+                  <a:pos x="T0" y="T1"/>
+                </a:cxn>
+                <a:cxn ang="0">
+                  <a:pos x="T2" y="T3"/>
+                </a:cxn>
+                <a:cxn ang="0">
+                  <a:pos x="T4" y="T5"/>
+                </a:cxn>
+                <a:cxn ang="0">
+                  <a:pos x="T6" y="T7"/>
+                </a:cxn>
+                <a:cxn ang="0">
+                  <a:pos x="T8" y="T9"/>
+                </a:cxn>
+                <a:cxn ang="0">
+                  <a:pos x="T10" y="T11"/>
+                </a:cxn>
+                <a:cxn ang="0">
+                  <a:pos x="T12" y="T13"/>
+                </a:cxn>
+              </a:cxnLst>
+              <a:rect l="0" t="0" r="r" b="b"/>
+              <a:pathLst>
+                <a:path w="274" h="468">
+                  <a:moveTo>
+                    <a:pt x="274" y="0"/>
+                  </a:moveTo>
+                  <a:lnTo>
+                    <a:pt x="274" y="310"/>
+                  </a:lnTo>
+                  <a:lnTo>
+                    <a:pt x="274" y="310"/>
+                  </a:lnTo>
+                  <a:lnTo>
+                    <a:pt x="0" y="468"/>
+                  </a:lnTo>
+                  <a:lnTo>
+                    <a:pt x="0" y="159"/>
+                  </a:lnTo>
+                  <a:lnTo>
+                    <a:pt x="274" y="0"/>
+                  </a:lnTo>
+                  <a:lnTo>
+                    <a:pt x="274" y="0"/>
+                  </a:lnTo>
+                  <a:close/>
+                </a:path>
+              </a:pathLst>
+            </a:custGeom>
+            <a:gradFill flip="none" rotWithShape="1">
+              <a:gsLst>
+                <a:gs pos="20000">
+                  <a:schemeClr val="bg2">
+                    <a:lumMod val="90000"/>
+                    <a:lumOff val="10000"/>
+                    <a:alpha val="20000"/>
+                  </a:schemeClr>
+                </a:gs>
+                <a:gs pos="100000">
+                  <a:schemeClr val="accent1">
+                    <a:lumMod val="60000"/>
+                    <a:lumOff val="40000"/>
+                    <a:alpha val="20000"/>
+                  </a:schemeClr>
+                </a:gs>
+              </a:gsLst>
+              <a:lin ang="18000000" scaled="0"/>
+              <a:tileRect/>
+            </a:gradFill>
+            <a:ln>
+              <a:noFill/>
+            </a:ln>
+            <a:effectLst>
+              <a:innerShdw blurRad="254000">
+                <a:schemeClr val="accent1">
+                  <a:lumMod val="60000"/>
+                  <a:lumOff val="40000"/>
+                  <a:alpha val="60000"/>
+                </a:schemeClr>
+              </a:innerShdw>
+            </a:effectLst>
+          </p:spPr>
+          <p:style>
+            <a:lnRef idx="2">
+              <a:schemeClr val="accent1">
+                <a:shade val="50000"/>
+              </a:schemeClr>
+            </a:lnRef>
+            <a:fillRef idx="1">
+              <a:schemeClr val="accent1"/>
+            </a:fillRef>
+            <a:effectRef idx="0">
+              <a:schemeClr val="accent1"/>
+            </a:effectRef>
+            <a:fontRef idx="minor">
+              <a:schemeClr val="lt1"/>
+            </a:fontRef>
+          </p:style>
+          <p:txBody>
+            <a:bodyPr rot="0" spcFirstLastPara="0" vertOverflow="overflow" horzOverflow="overflow" vert="horz" wrap="square" lIns="91440" tIns="45720" rIns="91440" bIns="45720" numCol="1" spcCol="0" rtlCol="0" fromWordArt="0" anchor="ctr" anchorCtr="0" forceAA="0" compatLnSpc="1">
+              <a:prstTxWarp prst="textNoShape">
+                <a:avLst/>
+              </a:prstTxWarp>
+              <a:noAutofit/>
+            </a:bodyPr>
+            <a:lstStyle>
+              <a:defPPr>
+                <a:defRPr lang="ru-RU"/>
+              </a:defPPr>
+            </a:lstStyle>
+            <a:p>
+              <a:pPr algn="ctr" rtl="0"/>
+              <a:endParaRPr lang="ru-RU" dirty="0">
+                <a:latin typeface="Calibri" panose="020F0502020204030204" pitchFamily="34" charset="0"/>
+              </a:endParaRPr>
+            </a:p>
+          </p:txBody>
+        </p:sp>
+      </p:grpSp>
+      <p:sp>
+        <p:nvSpPr>
+          <p:cNvPr id="2" name="Заголовок 1">
+            <a:extLst>
+              <a:ext uri="{FF2B5EF4-FFF2-40B4-BE49-F238E27FC236}">
+                <a16:creationId xmlns:a16="http://schemas.microsoft.com/office/drawing/2014/main" id="{338A15DE-D135-0710-9984-A0A55E960CB0}"/>
+              </a:ext>
+            </a:extLst>
+          </p:cNvPr>
+          <p:cNvSpPr>
+            <a:spLocks noGrp="1"/>
+          </p:cNvSpPr>
+          <p:nvPr>
+            <p:ph type="title"/>
+          </p:nvPr>
+        </p:nvSpPr>
+        <p:spPr>
+          <a:xfrm>
+            <a:off x="600974" y="196900"/>
+            <a:ext cx="4899628" cy="2331490"/>
+          </a:xfrm>
+          <a:noFill/>
+        </p:spPr>
+        <p:txBody>
+          <a:bodyPr rtlCol="0" anchor="b"/>
+          <a:lstStyle>
+            <a:defPPr>
+              <a:defRPr lang="ru-RU"/>
+            </a:defPPr>
+          </a:lstStyle>
+          <a:p>
+            <a:r>
+              <a:rPr lang="ru-RU" b="1" dirty="0"/>
+              <a:t>Заключение и Перспективы</a:t>
+            </a:r>
+          </a:p>
+        </p:txBody>
+      </p:sp>
+      <p:sp>
+        <p:nvSpPr>
+          <p:cNvPr id="3" name="Объект 2">
+            <a:extLst>
+              <a:ext uri="{FF2B5EF4-FFF2-40B4-BE49-F238E27FC236}">
+                <a16:creationId xmlns:a16="http://schemas.microsoft.com/office/drawing/2014/main" id="{ECC8AA23-D8D0-93BE-5C5F-103A750B0D2F}"/>
+              </a:ext>
+            </a:extLst>
+          </p:cNvPr>
+          <p:cNvSpPr>
+            <a:spLocks noGrp="1"/>
+          </p:cNvSpPr>
+          <p:nvPr>
+            <p:ph sz="half" idx="1"/>
+          </p:nvPr>
+        </p:nvSpPr>
+        <p:spPr>
+          <a:xfrm>
+            <a:off x="583162" y="2827209"/>
+            <a:ext cx="4917440" cy="3442144"/>
+          </a:xfrm>
+          <a:noFill/>
+        </p:spPr>
+        <p:txBody>
+          <a:bodyPr vert="horz" lIns="91440" tIns="45720" rIns="91440" bIns="45720" rtlCol="0" anchor="t">
+            <a:normAutofit/>
+          </a:bodyPr>
+          <a:lstStyle>
+            <a:defPPr>
+              <a:defRPr lang="ru-RU"/>
+            </a:defPPr>
+          </a:lstStyle>
+          <a:p>
+            <a:pPr marL="285750" indent="-285750">
+              <a:buFont typeface="Arial" panose="020B0604020202020204" pitchFamily="34" charset="0"/>
+              <a:buChar char="•"/>
+            </a:pPr>
+            <a:r>
+              <a:rPr lang="ru-RU" dirty="0"/>
+              <a:t>Итог: Построен чистый, стабильный и воспроизводимый </a:t>
+            </a:r>
+            <a:r>
+              <a:rPr lang="ru-RU" dirty="0" err="1"/>
+              <a:t>пайплайн</a:t>
+            </a:r>
+            <a:r>
+              <a:rPr lang="ru-RU" dirty="0"/>
+              <a:t>, устойчивый к химическим выбросам.</a:t>
+            </a:r>
+          </a:p>
+          <a:p>
+            <a:pPr marL="285750" indent="-285750">
+              <a:buFont typeface="Arial" panose="020B0604020202020204" pitchFamily="34" charset="0"/>
+              <a:buChar char="•"/>
+            </a:pPr>
+            <a:r>
+              <a:rPr lang="ru-RU" dirty="0"/>
+              <a:t>Что можно улучшить: Внедрение 3D-дескрипторов или </a:t>
+            </a:r>
+            <a:r>
+              <a:rPr lang="ru-RU" dirty="0" err="1"/>
+              <a:t>графовых</a:t>
+            </a:r>
+            <a:r>
+              <a:rPr lang="ru-RU" dirty="0"/>
+              <a:t> нейросетей (GNN) для явного кодирования пространственной изомерии молекул, которую не смогли отловить классические табличные фичи.</a:t>
+            </a:r>
+          </a:p>
+        </p:txBody>
+      </p:sp>
+      <p:pic>
+        <p:nvPicPr>
+          <p:cNvPr id="20" name="Рисунок 19" descr="График крупным планом">
+            <a:extLst>
+              <a:ext uri="{FF2B5EF4-FFF2-40B4-BE49-F238E27FC236}">
+                <a16:creationId xmlns:a16="http://schemas.microsoft.com/office/drawing/2014/main" id="{A7019768-5E2A-F9D1-62D6-EC7C5F0BBEC9}"/>
+              </a:ext>
+            </a:extLst>
+          </p:cNvPr>
+          <p:cNvPicPr>
+            <a:picLocks noGrp="1" noChangeAspect="1"/>
+          </p:cNvPicPr>
+          <p:nvPr>
+            <p:ph type="pic" sz="quarter" idx="13"/>
+          </p:nvPr>
+        </p:nvPicPr>
+        <p:blipFill>
+          <a:blip r:embed="rId3">
+            <a:extLst>
+              <a:ext uri="{28A0092B-C50C-407E-A947-70E740481C1C}">
+                <a14:useLocalDpi xmlns:a14="http://schemas.microsoft.com/office/drawing/2010/main" val="0"/>
+              </a:ext>
+            </a:extLst>
+          </a:blip>
+          <a:srcRect l="9" r="9"/>
+          <a:stretch/>
+        </p:blipFill>
+        <p:spPr>
+          <a:xfrm>
+            <a:off x="6095588" y="0"/>
+            <a:ext cx="6095998" cy="6858000"/>
+          </a:xfrm>
+        </p:spPr>
+      </p:pic>
+    </p:spTree>
+    <p:extLst>
+      <p:ext uri="{BB962C8B-B14F-4D97-AF65-F5344CB8AC3E}">
+        <p14:creationId xmlns:p14="http://schemas.microsoft.com/office/powerpoint/2010/main" val="414523832"/>
       </p:ext>
     </p:extLst>
   </p:cSld>
@@ -17428,15 +17544,6 @@
 </file>
 
 <file path=customXml/item1.xml><?xml version="1.0" encoding="utf-8"?>
-<?mso-contentType ?>
-<FormTemplates xmlns="http://schemas.microsoft.com/sharepoint/v3/contenttype/forms">
-  <Display>DocumentLibraryForm</Display>
-  <Edit>DocumentLibraryForm</Edit>
-  <New>DocumentLibraryForm</New>
-</FormTemplates>
-</file>
-
-<file path=customXml/item2.xml><?xml version="1.0" encoding="utf-8"?>
 <p:properties xmlns:p="http://schemas.microsoft.com/office/2006/metadata/properties" xmlns:xsi="http://www.w3.org/2001/XMLSchema-instance" xmlns:pc="http://schemas.microsoft.com/office/infopath/2007/PartnerControls">
   <documentManagement>
     <_ip_UnifiedCompliancePolicyUIAction xmlns="http://schemas.microsoft.com/sharepoint/v3" xsi:nil="true"/>
@@ -17454,6 +17561,15 @@
     <MediaServiceKeyPoints xmlns="71af3243-3dd4-4a8d-8c0d-dd76da1f02a5" xsi:nil="true"/>
   </documentManagement>
 </p:properties>
+</file>
+
+<file path=customXml/item2.xml><?xml version="1.0" encoding="utf-8"?>
+<?mso-contentType ?>
+<FormTemplates xmlns="http://schemas.microsoft.com/sharepoint/v3/contenttype/forms">
+  <Display>DocumentLibraryForm</Display>
+  <Edit>DocumentLibraryForm</Edit>
+  <New>DocumentLibraryForm</New>
+</FormTemplates>
 </file>
 
 <file path=customXml/item3.xml><?xml version="1.0" encoding="utf-8"?>
@@ -17769,14 +17885,6 @@
 </file>
 
 <file path=customXml/itemProps1.xml><?xml version="1.0" encoding="utf-8"?>
-<ds:datastoreItem xmlns:ds="http://schemas.openxmlformats.org/officeDocument/2006/customXml" ds:itemID="{2F49CD38-5B57-4682-9FCE-B9174068D0AE}">
-  <ds:schemaRefs>
-    <ds:schemaRef ds:uri="http://schemas.microsoft.com/sharepoint/v3/contenttype/forms"/>
-  </ds:schemaRefs>
-</ds:datastoreItem>
-</file>
-
-<file path=customXml/itemProps2.xml><?xml version="1.0" encoding="utf-8"?>
 <ds:datastoreItem xmlns:ds="http://schemas.openxmlformats.org/officeDocument/2006/customXml" ds:itemID="{1F342EE1-43E5-4AFB-895D-B61B9656DC14}">
   <ds:schemaRefs>
     <ds:schemaRef ds:uri="http://schemas.microsoft.com/office/2006/documentManagement/types"/>
@@ -17791,6 +17899,14 @@
     <ds:schemaRef ds:uri="230e9df3-be65-4c73-a93b-d1236ebd677e"/>
     <ds:schemaRef ds:uri="16c05727-aa75-4e4a-9b5f-8a80a1165891"/>
     <ds:schemaRef ds:uri="71af3243-3dd4-4a8d-8c0d-dd76da1f02a5"/>
+  </ds:schemaRefs>
+</ds:datastoreItem>
+</file>
+
+<file path=customXml/itemProps2.xml><?xml version="1.0" encoding="utf-8"?>
+<ds:datastoreItem xmlns:ds="http://schemas.openxmlformats.org/officeDocument/2006/customXml" ds:itemID="{2F49CD38-5B57-4682-9FCE-B9174068D0AE}">
+  <ds:schemaRefs>
+    <ds:schemaRef ds:uri="http://schemas.microsoft.com/sharepoint/v3/contenttype/forms"/>
   </ds:schemaRefs>
 </ds:datastoreItem>
 </file>

</xml_diff>